<commit_message>
fix(sd101): sd-02-004 — cloud chats are server-decryptable, secret chats are one-to-one
Network eavesdroppers cannot read client-server-encrypted cloud chats;
the risk is Telegram's server side. Secret chats are one-to-one chats
opened beside the normal chat. Lesson, metadata and deck slide 3
updated; PPTX re-exported.

Co-Authored-By: Claude Opus 5.5 <noreply@anthropic.com>
Claude-Session: https://claude.ai/code/session_01McBLtMnJbTnB94NeVs8a2V
</commit_message>
<xml_diff>
--- a/system-design-101/vi/lessons/sd-02-004/slides/sd-02-004.pptx
+++ b/system-design-101/vi/lessons/sd-02-004/slides/sd-02-004.pptx
@@ -4609,7 +4609,7 @@
               <a:buNone/>
             </a:pPr>
             <a:r>
-              <a:rPr lang="en-US" sz="2400" dirty="0" spc="-3" kern="0">
+              <a:rPr lang="en-US" sz="2400" dirty="0" spc="-12" kern="0">
                 <a:solidFill>
                   <a:srgbClr val="6B6A66"/>
                 </a:solidFill>
@@ -4617,7 +4617,7 @@
                 <a:ea typeface="Be Vietnam Pro" pitchFamily="34" charset="-122"/>
                 <a:cs typeface="Be Vietnam Pro" pitchFamily="34" charset="-120"/>
               </a:rPr>
-              <a:t>Theo</a:t>
+              <a:t>Máy</a:t>
             </a:r>
             <a:r>
               <a:rPr lang="en-US" sz="2400" dirty="0" spc="1" kern="0">
@@ -4628,10 +4628,10 @@
                 <a:ea typeface="Be Vietnam Pro" pitchFamily="34" charset="-122"/>
                 <a:cs typeface="Be Vietnam Pro" pitchFamily="34" charset="-120"/>
               </a:rPr>
-              <a:t> nguồn:</a:t>
-            </a:r>
-            <a:r>
-              <a:rPr lang="en-US" sz="2400" dirty="0" spc="-3" kern="0">
+              <a:t> chủ</a:t>
+            </a:r>
+            <a:r>
+              <a:rPr lang="en-US" sz="2400" dirty="0" spc="-34" kern="0">
                 <a:solidFill>
                   <a:srgbClr val="6B6A66"/>
                 </a:solidFill>
@@ -4639,10 +4639,10 @@
                 <a:ea typeface="Be Vietnam Pro" pitchFamily="34" charset="-122"/>
                 <a:cs typeface="Be Vietnam Pro" pitchFamily="34" charset="-120"/>
               </a:rPr>
-              <a:t> bên</a:t>
-            </a:r>
-            <a:r>
-              <a:rPr lang="en-US" sz="2400" dirty="0" spc="3" kern="0">
+              <a:t> Telegram</a:t>
+            </a:r>
+            <a:r>
+              <a:rPr lang="en-US" sz="2400" dirty="0" spc="1" kern="0">
                 <a:solidFill>
                   <a:srgbClr val="6B6A66"/>
                 </a:solidFill>
@@ -4650,10 +4650,10 @@
                 <a:ea typeface="Be Vietnam Pro" pitchFamily="34" charset="-122"/>
                 <a:cs typeface="Be Vietnam Pro" pitchFamily="34" charset="-120"/>
               </a:rPr>
-              <a:t> thứ</a:t>
-            </a:r>
-            <a:r>
-              <a:rPr lang="en-US" sz="2400" dirty="0" spc="-2" kern="0">
+              <a:t> giải</a:t>
+            </a:r>
+            <a:r>
+              <a:rPr lang="en-US" sz="2400" dirty="0" spc="4" kern="0">
                 <a:solidFill>
                   <a:srgbClr val="6B6A66"/>
                 </a:solidFill>
@@ -4661,10 +4661,10 @@
                 <a:ea typeface="Be Vietnam Pro" pitchFamily="34" charset="-122"/>
                 <a:cs typeface="Be Vietnam Pro" pitchFamily="34" charset="-120"/>
               </a:rPr>
-              <a:t> ba</a:t>
-            </a:r>
-            <a:r>
-              <a:rPr lang="en-US" sz="2400" dirty="0" spc="-17" kern="0">
+              <a:t> mã</a:t>
+            </a:r>
+            <a:r>
+              <a:rPr lang="en-US" sz="2400" dirty="0" spc="6" kern="0">
                 <a:solidFill>
                   <a:srgbClr val="6B6A66"/>
                 </a:solidFill>
@@ -4672,10 +4672,10 @@
                 <a:ea typeface="Be Vietnam Pro" pitchFamily="34" charset="-122"/>
                 <a:cs typeface="Be Vietnam Pro" pitchFamily="34" charset="-120"/>
               </a:rPr>
-              <a:t> về</a:t>
-            </a:r>
-            <a:r>
-              <a:rPr lang="en-US" sz="2400" dirty="0" spc="-12" kern="0">
+              <a:t> được;</a:t>
+            </a:r>
+            <a:r>
+              <a:rPr lang="en-US" sz="2400" dirty="0" spc="-38" kern="0">
                 <a:solidFill>
                   <a:srgbClr val="6B6A66"/>
                 </a:solidFill>
@@ -4683,10 +4683,10 @@
                 <a:ea typeface="Be Vietnam Pro" pitchFamily="34" charset="-122"/>
                 <a:cs typeface="Be Vietnam Pro" pitchFamily="34" charset="-120"/>
               </a:rPr>
-              <a:t> nguyên</a:t>
-            </a:r>
-            <a:r>
-              <a:rPr lang="en-US" sz="2400" dirty="0" spc="-10" kern="0">
+              <a:t> kẻ</a:t>
+            </a:r>
+            <a:r>
+              <a:rPr lang="en-US" sz="2400" dirty="0" spc="1" kern="0">
                 <a:solidFill>
                   <a:srgbClr val="6B6A66"/>
                 </a:solidFill>
@@ -4694,7 +4694,29 @@
                 <a:ea typeface="Be Vietnam Pro" pitchFamily="34" charset="-122"/>
                 <a:cs typeface="Be Vietnam Pro" pitchFamily="34" charset="-120"/>
               </a:rPr>
-              <a:t> tắc</a:t>
+              <a:t> nghe lén</a:t>
+            </a:r>
+            <a:r>
+              <a:rPr lang="en-US" sz="2400" dirty="0" spc="-18" kern="0">
+                <a:solidFill>
+                  <a:srgbClr val="6B6A66"/>
+                </a:solidFill>
+                <a:latin typeface="Be Vietnam Pro" pitchFamily="34" charset="0"/>
+                <a:ea typeface="Be Vietnam Pro" pitchFamily="34" charset="-122"/>
+                <a:cs typeface="Be Vietnam Pro" pitchFamily="34" charset="-120"/>
+              </a:rPr>
+              <a:t> trên</a:t>
+            </a:r>
+            <a:r>
+              <a:rPr lang="en-US" sz="2400" dirty="0" spc="4" kern="0">
+                <a:solidFill>
+                  <a:srgbClr val="6B6A66"/>
+                </a:solidFill>
+                <a:latin typeface="Be Vietnam Pro" pitchFamily="34" charset="0"/>
+                <a:ea typeface="Be Vietnam Pro" pitchFamily="34" charset="-122"/>
+                <a:cs typeface="Be Vietnam Pro" pitchFamily="34" charset="-120"/>
+              </a:rPr>
+              <a:t> mạng</a:t>
             </a:r>
             <a:r>
               <a:rPr lang="en-US" sz="2400" dirty="0" spc="0" kern="0">
@@ -4705,7 +4727,7 @@
                 <a:ea typeface="Be Vietnam Pro" pitchFamily="34" charset="-122"/>
                 <a:cs typeface="Be Vietnam Pro" pitchFamily="34" charset="-120"/>
               </a:rPr>
-              <a:t> có</a:t>
+              <a:t> thì</a:t>
             </a:r>
             <a:r>
               <a:rPr lang="en-US" sz="2400" dirty="0" spc="1" kern="0">
@@ -4716,51 +4738,7 @@
                 <a:ea typeface="Be Vietnam Pro" pitchFamily="34" charset="-122"/>
                 <a:cs typeface="Be Vietnam Pro" pitchFamily="34" charset="-120"/>
               </a:rPr>
-              <a:t> thể</a:t>
-            </a:r>
-            <a:r>
-              <a:rPr lang="en-US" sz="2400" dirty="0" spc="0" kern="0">
-                <a:solidFill>
-                  <a:srgbClr val="6B6A66"/>
-                </a:solidFill>
-                <a:latin typeface="Be Vietnam Pro" pitchFamily="34" charset="0"/>
-                <a:ea typeface="Be Vietnam Pro" pitchFamily="34" charset="-122"/>
-                <a:cs typeface="Be Vietnam Pro" pitchFamily="34" charset="-120"/>
-              </a:rPr>
-              <a:t> chặn</a:t>
-            </a:r>
-            <a:r>
-              <a:rPr lang="en-US" sz="2400" dirty="0" spc="-15" kern="0">
-                <a:solidFill>
-                  <a:srgbClr val="6B6A66"/>
-                </a:solidFill>
-                <a:latin typeface="Be Vietnam Pro" pitchFamily="34" charset="0"/>
-                <a:ea typeface="Be Vietnam Pro" pitchFamily="34" charset="-122"/>
-                <a:cs typeface="Be Vietnam Pro" pitchFamily="34" charset="-120"/>
-              </a:rPr>
-              <a:t> và</a:t>
-            </a:r>
-            <a:r>
-              <a:rPr lang="en-US" sz="2400" dirty="0" spc="9" kern="0">
-                <a:solidFill>
-                  <a:srgbClr val="6B6A66"/>
-                </a:solidFill>
-                <a:latin typeface="Be Vietnam Pro" pitchFamily="34" charset="0"/>
-                <a:ea typeface="Be Vietnam Pro" pitchFamily="34" charset="-122"/>
-                <a:cs typeface="Be Vietnam Pro" pitchFamily="34" charset="-120"/>
-              </a:rPr>
-              <a:t> đọc</a:t>
-            </a:r>
-            <a:r>
-              <a:rPr lang="en-US" sz="2400" dirty="0" spc="0" kern="0">
-                <a:solidFill>
-                  <a:srgbClr val="6B6A66"/>
-                </a:solidFill>
-                <a:latin typeface="Be Vietnam Pro" pitchFamily="34" charset="0"/>
-                <a:ea typeface="Be Vietnam Pro" pitchFamily="34" charset="-122"/>
-                <a:cs typeface="Be Vietnam Pro" pitchFamily="34" charset="-120"/>
-              </a:rPr>
-              <a:t> tin.</a:t>
+              <a:t> không.</a:t>
             </a:r>
             <a:endParaRPr lang="en-US" sz="2400" dirty="0"/>
           </a:p>

</xml_diff>

<commit_message>
sd-02-004: both endpoints of a secret chat can decrypt
E2EE now reads as decryptable only at the two ends of the chat, in the
lesson, its alt text, the figure and the deck (PPTX re-exported).

Co-Authored-By: Claude Opus 5.5 <noreply@anthropic.com>
Claude-Session: https://claude.ai/code/session_01McBLtMnJbTnB94NeVs8a2V
</commit_message>
<xml_diff>
--- a/system-design-101/vi/lessons/sd-02-004/slides/sd-02-004.pptx
+++ b/system-design-101/vi/lessons/sd-02-004/slides/sd-02-004.pptx
@@ -2644,6 +2644,17 @@
               <a:t>chỉ</a:t>
             </a:r>
             <a:r>
+              <a:rPr lang="en-US" sz="2100" dirty="0" spc="0" kern="0">
+                <a:solidFill>
+                  <a:srgbClr val="C4C8D6"/>
+                </a:solidFill>
+                <a:latin typeface="Be Vietnam Pro" pitchFamily="34" charset="0"/>
+                <a:ea typeface="Be Vietnam Pro" pitchFamily="34" charset="-122"/>
+                <a:cs typeface="Be Vietnam Pro" pitchFamily="34" charset="-120"/>
+              </a:rPr>
+              <a:t> hai</a:t>
+            </a:r>
+            <a:r>
               <a:rPr lang="en-US" sz="2100" dirty="0" spc="-10" kern="0">
                 <a:solidFill>
                   <a:srgbClr val="C4C8D6"/>
@@ -2655,7 +2666,7 @@
               <a:t> máy</a:t>
             </a:r>
             <a:r>
-              <a:rPr lang="en-US" sz="2100" dirty="0" spc="4" kern="0">
+              <a:rPr lang="en-US" sz="2100" dirty="0" spc="-6" kern="0">
                 <a:solidFill>
                   <a:srgbClr val="C4C8D6"/>
                 </a:solidFill>
@@ -2663,7 +2674,29 @@
                 <a:ea typeface="Be Vietnam Pro" pitchFamily="34" charset="-122"/>
                 <a:cs typeface="Be Vietnam Pro" pitchFamily="34" charset="-120"/>
               </a:rPr>
-              <a:t> người</a:t>
+              <a:t> ở</a:t>
+            </a:r>
+            <a:r>
+              <a:rPr lang="en-US" sz="2100" dirty="0" spc="-1" kern="0">
+                <a:solidFill>
+                  <a:srgbClr val="C4C8D6"/>
+                </a:solidFill>
+                <a:latin typeface="Be Vietnam Pro" pitchFamily="34" charset="0"/>
+                <a:ea typeface="Be Vietnam Pro" pitchFamily="34" charset="-122"/>
+                <a:cs typeface="Be Vietnam Pro" pitchFamily="34" charset="-120"/>
+              </a:rPr>
+              <a:t> hai</a:t>
+            </a:r>
+            <a:r>
+              <a:rPr lang="en-US" sz="2100" dirty="0" spc="10" kern="0">
+                <a:solidFill>
+                  <a:srgbClr val="C4C8D6"/>
+                </a:solidFill>
+                <a:latin typeface="Be Vietnam Pro" pitchFamily="34" charset="0"/>
+                <a:ea typeface="Be Vietnam Pro" pitchFamily="34" charset="-122"/>
+                <a:cs typeface="Be Vietnam Pro" pitchFamily="34" charset="-120"/>
+              </a:rPr>
+              <a:t> đầu</a:t>
             </a:r>
             <a:r>
               <a:rPr lang="en-US" sz="2100" dirty="0" spc="0" kern="0">
@@ -2674,10 +2707,10 @@
                 <a:ea typeface="Be Vietnam Pro" pitchFamily="34" charset="-122"/>
                 <a:cs typeface="Be Vietnam Pro" pitchFamily="34" charset="-120"/>
               </a:rPr>
-              <a:t> nhận giải</a:t>
-            </a:r>
-            <a:r>
-              <a:rPr lang="en-US" sz="2100" dirty="0" spc="-2" kern="0">
+              <a:t> giải</a:t>
+            </a:r>
+            <a:r>
+              <a:rPr lang="en-US" sz="2100" dirty="0" spc="-3" kern="0">
                 <a:solidFill>
                   <a:srgbClr val="C4C8D6"/>
                 </a:solidFill>
@@ -2903,7 +2936,7 @@
               <a:t> chỉ</a:t>
             </a:r>
             <a:r>
-              <a:rPr lang="en-US" sz="7800" dirty="0" spc="-75" kern="0">
+              <a:rPr lang="en-US" sz="7800" dirty="0" spc="0" kern="0">
                 <a:solidFill>
                   <a:srgbClr val="14161C"/>
                 </a:solidFill>
@@ -2911,10 +2944,10 @@
                 <a:ea typeface="Bricolage Grotesque ExtraBold" pitchFamily="34" charset="-122"/>
                 <a:cs typeface="Bricolage Grotesque ExtraBold" pitchFamily="34" charset="-120"/>
               </a:rPr>
-              <a:t> người</a:t>
-            </a:r>
-            <a:r>
-              <a:rPr lang="en-US" sz="7800" dirty="0" spc="-4" kern="0">
+              <a:t> hai</a:t>
+            </a:r>
+            <a:r>
+              <a:rPr lang="en-US" sz="7800" dirty="0" spc="10" kern="0">
                 <a:solidFill>
                   <a:srgbClr val="14161C"/>
                 </a:solidFill>
@@ -2922,7 +2955,18 @@
                 <a:ea typeface="Bricolage Grotesque ExtraBold" pitchFamily="34" charset="-122"/>
                 <a:cs typeface="Bricolage Grotesque ExtraBold" pitchFamily="34" charset="-120"/>
               </a:rPr>
-              <a:t> nhận</a:t>
+              <a:t> đầu</a:t>
+            </a:r>
+            <a:r>
+              <a:rPr lang="en-US" sz="7800" dirty="0" spc="-1" kern="0">
+                <a:solidFill>
+                  <a:srgbClr val="14161C"/>
+                </a:solidFill>
+                <a:latin typeface="Bricolage Grotesque ExtraBold" pitchFamily="34" charset="0"/>
+                <a:ea typeface="Bricolage Grotesque ExtraBold" pitchFamily="34" charset="-122"/>
+                <a:cs typeface="Bricolage Grotesque ExtraBold" pitchFamily="34" charset="-120"/>
+              </a:rPr>
+              <a:t> chat</a:t>
             </a:r>
             <a:r>
               <a:rPr lang="en-US" sz="7800" dirty="0" spc="-2" kern="0">
@@ -3112,6 +3156,83 @@
               <a:t>Chỉ</a:t>
             </a:r>
             <a:r>
+              <a:rPr lang="en-US" sz="2850" dirty="0" spc="3" kern="0">
+                <a:solidFill>
+                  <a:srgbClr val="14161C"/>
+                </a:solidFill>
+                <a:latin typeface="Be Vietnam Pro" pitchFamily="34" charset="0"/>
+                <a:ea typeface="Be Vietnam Pro" pitchFamily="34" charset="-122"/>
+                <a:cs typeface="Be Vietnam Pro" pitchFamily="34" charset="-120"/>
+              </a:rPr>
+              <a:t> hai</a:t>
+            </a:r>
+            <a:r>
+              <a:rPr lang="en-US" sz="2850" dirty="0" spc="-11" kern="0">
+                <a:solidFill>
+                  <a:srgbClr val="14161C"/>
+                </a:solidFill>
+                <a:latin typeface="Be Vietnam Pro" pitchFamily="34" charset="0"/>
+                <a:ea typeface="Be Vietnam Pro" pitchFamily="34" charset="-122"/>
+                <a:cs typeface="Be Vietnam Pro" pitchFamily="34" charset="-120"/>
+              </a:rPr>
+              <a:t> máy</a:t>
+            </a:r>
+            <a:r>
+              <a:rPr lang="en-US" sz="2850" dirty="0" spc="0" kern="0">
+                <a:solidFill>
+                  <a:srgbClr val="14161C"/>
+                </a:solidFill>
+                <a:latin typeface="Be Vietnam Pro" pitchFamily="34" charset="0"/>
+                <a:ea typeface="Be Vietnam Pro" pitchFamily="34" charset="-122"/>
+                <a:cs typeface="Be Vietnam Pro" pitchFamily="34" charset="-120"/>
+              </a:rPr>
+              <a:t> ở</a:t>
+            </a:r>
+            <a:r>
+              <a:rPr lang="en-US" sz="2850" dirty="0" spc="3" kern="0">
+                <a:solidFill>
+                  <a:srgbClr val="14161C"/>
+                </a:solidFill>
+                <a:latin typeface="Be Vietnam Pro" pitchFamily="34" charset="0"/>
+                <a:ea typeface="Be Vietnam Pro" pitchFamily="34" charset="-122"/>
+                <a:cs typeface="Be Vietnam Pro" pitchFamily="34" charset="-120"/>
+              </a:rPr>
+              <a:t> hai</a:t>
+            </a:r>
+            <a:r>
+              <a:rPr lang="en-US" sz="2850" dirty="0" spc="15" kern="0">
+                <a:solidFill>
+                  <a:srgbClr val="14161C"/>
+                </a:solidFill>
+                <a:latin typeface="Be Vietnam Pro" pitchFamily="34" charset="0"/>
+                <a:ea typeface="Be Vietnam Pro" pitchFamily="34" charset="-122"/>
+                <a:cs typeface="Be Vietnam Pro" pitchFamily="34" charset="-120"/>
+              </a:rPr>
+              <a:t> đầu</a:t>
+            </a:r>
+            <a:r>
+              <a:rPr lang="en-US" sz="2850" dirty="0" spc="-3" kern="0">
+                <a:solidFill>
+                  <a:srgbClr val="14161C"/>
+                </a:solidFill>
+                <a:latin typeface="Be Vietnam Pro" pitchFamily="34" charset="0"/>
+                <a:ea typeface="Be Vietnam Pro" pitchFamily="34" charset="-122"/>
+                <a:cs typeface="Be Vietnam Pro" pitchFamily="34" charset="-120"/>
+              </a:rPr>
+              <a:t> cuộc</a:t>
+            </a:r>
+            <a:r>
+              <a:rPr lang="en-US" sz="2850" dirty="0" spc="-12" kern="0">
+                <a:solidFill>
+                  <a:srgbClr val="14161C"/>
+                </a:solidFill>
+                <a:latin typeface="Be Vietnam Pro" pitchFamily="34" charset="0"/>
+                <a:ea typeface="Be Vietnam Pro" pitchFamily="34" charset="-122"/>
+                <a:cs typeface="Be Vietnam Pro" pitchFamily="34" charset="-120"/>
+              </a:rPr>
+              <a:t> chat</a:t>
+            </a:r>
+            <a:r>
               <a:rPr lang="en-US" sz="2850" dirty="0" spc="1" kern="0">
                 <a:solidFill>
                   <a:srgbClr val="14161C"/>
@@ -3120,10 +3241,10 @@
                 <a:ea typeface="Be Vietnam Pro" pitchFamily="34" charset="-122"/>
                 <a:cs typeface="Be Vietnam Pro" pitchFamily="34" charset="-120"/>
               </a:rPr>
-              <a:t> phía</a:t>
-            </a:r>
-            <a:r>
-              <a:rPr lang="en-US" sz="2850" dirty="0" spc="7" kern="0">
+              <a:t> giải</a:t>
+            </a:r>
+            <a:r>
+              <a:rPr lang="en-US" sz="2850" dirty="0" spc="0" kern="0">
                 <a:solidFill>
                   <a:srgbClr val="14161C"/>
                 </a:solidFill>
@@ -3131,29 +3252,7 @@
                 <a:ea typeface="Be Vietnam Pro" pitchFamily="34" charset="-122"/>
                 <a:cs typeface="Be Vietnam Pro" pitchFamily="34" charset="-120"/>
               </a:rPr>
-              <a:t> người</a:t>
-            </a:r>
-            <a:r>
-              <a:rPr lang="en-US" sz="2850" dirty="0" spc="-1" kern="0">
-                <a:solidFill>
-                  <a:srgbClr val="14161C"/>
-                </a:solidFill>
-                <a:latin typeface="Be Vietnam Pro" pitchFamily="34" charset="0"/>
-                <a:ea typeface="Be Vietnam Pro" pitchFamily="34" charset="-122"/>
-                <a:cs typeface="Be Vietnam Pro" pitchFamily="34" charset="-120"/>
-              </a:rPr>
-              <a:t> nhận</a:t>
-            </a:r>
-            <a:r>
-              <a:rPr lang="en-US" sz="2850" dirty="0" spc="0" kern="0">
-                <a:solidFill>
-                  <a:srgbClr val="14161C"/>
-                </a:solidFill>
-                <a:latin typeface="Be Vietnam Pro" pitchFamily="34" charset="0"/>
-                <a:ea typeface="Be Vietnam Pro" pitchFamily="34" charset="-122"/>
-                <a:cs typeface="Be Vietnam Pro" pitchFamily="34" charset="-120"/>
-              </a:rPr>
-              <a:t> giải mã</a:t>
+              <a:t> mã</a:t>
             </a:r>
             <a:r>
               <a:rPr lang="en-US" sz="2850" dirty="0" spc="8" kern="0">
@@ -6973,10 +7072,10 @@
                 <a:ea typeface="Be Vietnam Pro" pitchFamily="34" charset="-122"/>
                 <a:cs typeface="Be Vietnam Pro" pitchFamily="34" charset="-120"/>
               </a:rPr>
-              <a:t>Chỉ</a:t>
-            </a:r>
-            <a:r>
-              <a:rPr lang="en-US" sz="2400" b="1" dirty="0" spc="3" kern="0">
+              <a:t>Chỉ hai</a:t>
+            </a:r>
+            <a:r>
+              <a:rPr lang="en-US" sz="2400" b="1" dirty="0" spc="11" kern="0">
                 <a:solidFill>
                   <a:srgbClr val="0F766E"/>
                 </a:solidFill>
@@ -6984,10 +7083,10 @@
                 <a:ea typeface="Be Vietnam Pro" pitchFamily="34" charset="-122"/>
                 <a:cs typeface="Be Vietnam Pro" pitchFamily="34" charset="-120"/>
               </a:rPr>
-              <a:t> ở</a:t>
-            </a:r>
-            <a:r>
-              <a:rPr lang="en-US" sz="2400" b="1" dirty="0" spc="-1" kern="0">
+              <a:t> đầu</a:t>
+            </a:r>
+            <a:r>
+              <a:rPr lang="en-US" sz="2400" b="1" dirty="0" spc="-7" kern="0">
                 <a:solidFill>
                   <a:srgbClr val="0F766E"/>
                 </a:solidFill>
@@ -6995,10 +7094,10 @@
                 <a:ea typeface="Be Vietnam Pro" pitchFamily="34" charset="-122"/>
                 <a:cs typeface="Be Vietnam Pro" pitchFamily="34" charset="-120"/>
               </a:rPr>
-              <a:t> đây</a:t>
-            </a:r>
-            <a:r>
-              <a:rPr lang="en-US" sz="2400" b="1" dirty="0" spc="0" kern="0">
+              <a:t> chat</a:t>
+            </a:r>
+            <a:r>
+              <a:rPr lang="en-US" sz="2400" b="1" dirty="0" spc="1" kern="0">
                 <a:solidFill>
                   <a:srgbClr val="0F766E"/>
                 </a:solidFill>
@@ -7009,7 +7108,7 @@
               <a:t> giải</a:t>
             </a:r>
             <a:r>
-              <a:rPr lang="en-US" sz="2400" b="1" dirty="0" spc="-2" kern="0">
+              <a:rPr lang="en-US" sz="2400" b="1" dirty="0" spc="-3" kern="0">
                 <a:solidFill>
                   <a:srgbClr val="0F766E"/>
                 </a:solidFill>
@@ -11824,7 +11923,7 @@
                 <a:ea typeface="Be Vietnam Pro" pitchFamily="34" charset="-122"/>
                 <a:cs typeface="Be Vietnam Pro" pitchFamily="34" charset="-120"/>
               </a:rPr>
-              <a:t> chỉ</a:t>
+              <a:t> chỉ hai</a:t>
             </a:r>
             <a:r>
               <a:rPr lang="en-US" sz="2400" dirty="0" spc="-6" kern="0">
@@ -11838,7 +11937,7 @@
               <a:t> máy</a:t>
             </a:r>
             <a:r>
-              <a:rPr lang="en-US" sz="2400" dirty="0" spc="6" kern="0">
+              <a:rPr lang="en-US" sz="2400" dirty="0" spc="2" kern="0">
                 <a:solidFill>
                   <a:srgbClr val="E4E1D8"/>
                 </a:solidFill>
@@ -11846,7 +11945,29 @@
                 <a:ea typeface="Be Vietnam Pro" pitchFamily="34" charset="-122"/>
                 <a:cs typeface="Be Vietnam Pro" pitchFamily="34" charset="-120"/>
               </a:rPr>
-              <a:t> người</a:t>
+              <a:t> ở</a:t>
+            </a:r>
+            <a:r>
+              <a:rPr lang="en-US" sz="2400" dirty="0" spc="0" kern="0">
+                <a:solidFill>
+                  <a:srgbClr val="E4E1D8"/>
+                </a:solidFill>
+                <a:latin typeface="Be Vietnam Pro" pitchFamily="34" charset="0"/>
+                <a:ea typeface="Be Vietnam Pro" pitchFamily="34" charset="-122"/>
+                <a:cs typeface="Be Vietnam Pro" pitchFamily="34" charset="-120"/>
+              </a:rPr>
+              <a:t> hai</a:t>
+            </a:r>
+            <a:r>
+              <a:rPr lang="en-US" sz="2400" dirty="0" spc="13" kern="0">
+                <a:solidFill>
+                  <a:srgbClr val="E4E1D8"/>
+                </a:solidFill>
+                <a:latin typeface="Be Vietnam Pro" pitchFamily="34" charset="0"/>
+                <a:ea typeface="Be Vietnam Pro" pitchFamily="34" charset="-122"/>
+                <a:cs typeface="Be Vietnam Pro" pitchFamily="34" charset="-120"/>
+              </a:rPr>
+              <a:t> đầu</a:t>
             </a:r>
             <a:r>
               <a:rPr lang="en-US" sz="2400" dirty="0" spc="1" kern="0">
@@ -11857,7 +11978,7 @@
                 <a:ea typeface="Be Vietnam Pro" pitchFamily="34" charset="-122"/>
                 <a:cs typeface="Be Vietnam Pro" pitchFamily="34" charset="-120"/>
               </a:rPr>
-              <a:t> nhận giải</a:t>
+              <a:t> giải</a:t>
             </a:r>
             <a:r>
               <a:rPr lang="en-US" sz="2400" dirty="0" spc="3" kern="0">

</xml_diff>

<commit_message>
sd-02-004: the server relays secret-chat ciphertext rather than keeping it
Co-Authored-By: Claude Opus 5.5 <noreply@anthropic.com>
Claude-Session: https://claude.ai/code/session_01McBLtMnJbTnB94NeVs8a2V
</commit_message>
<xml_diff>
--- a/system-design-101/vi/lessons/sd-02-004/slides/sd-02-004.pptx
+++ b/system-design-101/vi/lessons/sd-02-004/slides/sd-02-004.pptx
@@ -9637,6 +9637,28 @@
               <a:t> chỉ</a:t>
             </a:r>
             <a:r>
+              <a:rPr lang="en-US" sz="2550" dirty="0" spc="-12" kern="0">
+                <a:solidFill>
+                  <a:srgbClr val="F3EEE3"/>
+                </a:solidFill>
+                <a:latin typeface="Be Vietnam Pro" pitchFamily="34" charset="0"/>
+                <a:ea typeface="Be Vietnam Pro" pitchFamily="34" charset="-122"/>
+                <a:cs typeface="Be Vietnam Pro" pitchFamily="34" charset="-120"/>
+              </a:rPr>
+              <a:t> chuyển</a:t>
+            </a:r>
+            <a:r>
+              <a:rPr lang="en-US" sz="2550" dirty="0" spc="1" kern="0">
+                <a:solidFill>
+                  <a:srgbClr val="F3EEE3"/>
+                </a:solidFill>
+                <a:latin typeface="Be Vietnam Pro" pitchFamily="34" charset="0"/>
+                <a:ea typeface="Be Vietnam Pro" pitchFamily="34" charset="-122"/>
+                <a:cs typeface="Be Vietnam Pro" pitchFamily="34" charset="-120"/>
+              </a:rPr>
+              <a:t> tiếp</a:t>
+            </a:r>
+            <a:r>
               <a:rPr lang="en-US" sz="2550" dirty="0" spc="-2" kern="0">
                 <a:solidFill>
                   <a:srgbClr val="F3EEE3"/>
@@ -9645,7 +9667,7 @@
                 <a:ea typeface="Be Vietnam Pro" pitchFamily="34" charset="-122"/>
                 <a:cs typeface="Be Vietnam Pro" pitchFamily="34" charset="-120"/>
               </a:rPr>
-              <a:t> giữ dữ</a:t>
+              <a:t> dữ</a:t>
             </a:r>
             <a:r>
               <a:rPr lang="en-US" sz="2550" dirty="0" spc="1" kern="0">
@@ -9659,7 +9681,7 @@
               <a:t> liệu</a:t>
             </a:r>
             <a:r>
-              <a:rPr lang="en-US" sz="2550" dirty="0" spc="19" kern="0">
+              <a:rPr lang="en-US" sz="2550" dirty="0" spc="18" kern="0">
                 <a:solidFill>
                   <a:srgbClr val="F3EEE3"/>
                 </a:solidFill>

</xml_diff>

<commit_message>
sd101 decks: align sd-02-004 and 18 other decks with their lessons
sd-02-004: the key, not the message, is split into parts; fixed on
slides 1, 3, 4, 7. Other decks: restore conditions, attribution and
'the source does not say' caveats the lessons carry.

Co-Authored-By: Claude Sonnet 5.5 <noreply@anthropic.com>
Claude-Session: https://claude.ai/code/session_01JymsVQ3y9VySwCzo9bbdAp
</commit_message>
<xml_diff>
--- a/system-design-101/vi/lessons/sd-02-004/slides/sd-02-004.pptx
+++ b/system-design-101/vi/lessons/sd-02-004/slides/sd-02-004.pptx
@@ -2359,7 +2359,7 @@
               <a:buNone/>
             </a:pPr>
             <a:r>
-              <a:rPr lang="en-US" sz="2100" dirty="0" spc="2" kern="0">
+              <a:rPr lang="en-US" sz="2100" dirty="0" spc="0" kern="0">
                 <a:solidFill>
                   <a:srgbClr val="C4C8D6"/>
                 </a:solidFill>
@@ -2367,10 +2367,10 @@
                 <a:ea typeface="Be Vietnam Pro" pitchFamily="34" charset="-122"/>
                 <a:cs typeface="Be Vietnam Pro" pitchFamily="34" charset="-120"/>
               </a:rPr>
-              <a:t>tin</a:t>
-            </a:r>
-            <a:r>
-              <a:rPr lang="en-US" sz="2100" dirty="0" spc="-18" kern="0">
+              <a:t>chìa</a:t>
+            </a:r>
+            <a:r>
+              <a:rPr lang="en-US" sz="2100" dirty="0" spc="-4" kern="0">
                 <a:solidFill>
                   <a:srgbClr val="C4C8D6"/>
                 </a:solidFill>
@@ -2378,7 +2378,7 @@
                 <a:ea typeface="Be Vietnam Pro" pitchFamily="34" charset="-122"/>
                 <a:cs typeface="Be Vietnam Pro" pitchFamily="34" charset="-120"/>
               </a:rPr>
-              <a:t> và</a:t>
+              <a:t> khóa</a:t>
             </a:r>
             <a:r>
               <a:rPr lang="en-US" sz="2100" dirty="0" spc="0" kern="0">
@@ -2389,10 +2389,10 @@
                 <a:ea typeface="Be Vietnam Pro" pitchFamily="34" charset="-122"/>
                 <a:cs typeface="Be Vietnam Pro" pitchFamily="34" charset="-120"/>
               </a:rPr>
-              <a:t> chìa</a:t>
-            </a:r>
-            <a:r>
-              <a:rPr lang="en-US" sz="2100" dirty="0" spc="-4" kern="0">
+              <a:t> chia</a:t>
+            </a:r>
+            <a:r>
+              <a:rPr lang="en-US" sz="2100" dirty="0" spc="-2" kern="0">
                 <a:solidFill>
                   <a:srgbClr val="C4C8D6"/>
                 </a:solidFill>
@@ -2400,10 +2400,10 @@
                 <a:ea typeface="Be Vietnam Pro" pitchFamily="34" charset="-122"/>
                 <a:cs typeface="Be Vietnam Pro" pitchFamily="34" charset="-120"/>
               </a:rPr>
-              <a:t> khóa</a:t>
-            </a:r>
-            <a:r>
-              <a:rPr lang="en-US" sz="2100" dirty="0" spc="-1" kern="0">
+              <a:t> phần,</a:t>
+            </a:r>
+            <a:r>
+              <a:rPr lang="en-US" sz="2100" dirty="0" spc="-13" kern="0">
                 <a:solidFill>
                   <a:srgbClr val="C4C8D6"/>
                 </a:solidFill>
@@ -2411,7 +2411,7 @@
                 <a:ea typeface="Be Vietnam Pro" pitchFamily="34" charset="-122"/>
                 <a:cs typeface="Be Vietnam Pro" pitchFamily="34" charset="-120"/>
               </a:rPr>
-              <a:t> chia mảnh,</a:t>
+              <a:t> cất</a:t>
             </a:r>
             <a:r>
               <a:rPr lang="en-US" sz="2100" dirty="0" spc="1" kern="0">
@@ -2425,7 +2425,7 @@
               <a:t> nhiều</a:t>
             </a:r>
             <a:r>
-              <a:rPr lang="en-US" sz="2100" dirty="0" spc="5" kern="0">
+              <a:rPr lang="en-US" sz="2100" dirty="0" spc="0" kern="0">
                 <a:solidFill>
                   <a:srgbClr val="C4C8D6"/>
                 </a:solidFill>
@@ -2433,7 +2433,7 @@
                 <a:ea typeface="Be Vietnam Pro" pitchFamily="34" charset="-122"/>
                 <a:cs typeface="Be Vietnam Pro" pitchFamily="34" charset="-120"/>
               </a:rPr>
-              <a:t> nước</a:t>
+              <a:t> nơi</a:t>
             </a:r>
             <a:endParaRPr lang="en-US" sz="2100" dirty="0"/>
           </a:p>
@@ -4357,7 +4357,7 @@
                         <a:buNone/>
                       </a:pPr>
                       <a:r>
-                        <a:rPr lang="en-US" sz="2700" dirty="0" spc="-13" kern="0">
+                        <a:rPr lang="en-US" sz="2700" dirty="0" spc="0" kern="0">
                           <a:solidFill>
                             <a:srgbClr val="14161C"/>
                           </a:solidFill>
@@ -4365,7 +4365,7 @@
                           <a:ea typeface="Be Vietnam Pro" pitchFamily="34" charset="-122"/>
                           <a:cs typeface="Be Vietnam Pro" pitchFamily="34" charset="-120"/>
                         </a:rPr>
-                        <a:t>Máy</a:t>
+                        <a:t>Nhiều</a:t>
                       </a:r>
                       <a:r>
                         <a:rPr lang="en-US" sz="2700" dirty="0" spc="-1" kern="0">
@@ -4376,10 +4376,10 @@
                           <a:ea typeface="Be Vietnam Pro" pitchFamily="34" charset="-122"/>
                           <a:cs typeface="Be Vietnam Pro" pitchFamily="34" charset="-120"/>
                         </a:rPr>
-                        <a:t> chủ</a:t>
+                        <a:t> trung</a:t>
                       </a:r>
                       <a:r>
-                        <a:rPr lang="en-US" sz="2700" dirty="0" spc="-36" kern="0">
+                        <a:rPr lang="en-US" sz="2700" dirty="0" spc="-13" kern="0">
                           <a:solidFill>
                             <a:srgbClr val="14161C"/>
                           </a:solidFill>
@@ -4387,10 +4387,10 @@
                           <a:ea typeface="Be Vietnam Pro" pitchFamily="34" charset="-122"/>
                           <a:cs typeface="Be Vietnam Pro" pitchFamily="34" charset="-120"/>
                         </a:rPr>
-                        <a:t> Telegram,</a:t>
+                        <a:t> tâm</a:t>
                       </a:r>
                       <a:r>
-                        <a:rPr lang="en-US" sz="2700" dirty="0" spc="-1" kern="0">
+                        <a:rPr lang="en-US" sz="2700" dirty="0" spc="-4" kern="0">
                           <a:solidFill>
                             <a:srgbClr val="14161C"/>
                           </a:solidFill>
@@ -4398,10 +4398,21 @@
                           <a:ea typeface="Be Vietnam Pro" pitchFamily="34" charset="-122"/>
                           <a:cs typeface="Be Vietnam Pro" pitchFamily="34" charset="-120"/>
                         </a:rPr>
-                        <a:t> dạng</a:t>
+                        <a:t> dữ</a:t>
                       </a:r>
                       <a:r>
-                        <a:rPr lang="en-US" sz="2700" dirty="0" spc="16" kern="0">
+                        <a:rPr lang="en-US" sz="2700" dirty="0" spc="0" kern="0">
+                          <a:solidFill>
+                            <a:srgbClr val="14161C"/>
+                          </a:solidFill>
+                          <a:latin typeface="Be Vietnam Pro" pitchFamily="34" charset="0"/>
+                          <a:ea typeface="Be Vietnam Pro" pitchFamily="34" charset="-122"/>
+                          <a:cs typeface="Be Vietnam Pro" pitchFamily="34" charset="-120"/>
+                        </a:rPr>
+                        <a:t> liệu,</a:t>
+                      </a:r>
+                      <a:r>
+                        <a:rPr lang="en-US" sz="2700" dirty="0" spc="17" kern="0">
                           <a:solidFill>
                             <a:srgbClr val="14161C"/>
                           </a:solidFill>
@@ -4486,7 +4497,7 @@
                         <a:buNone/>
                       </a:pPr>
                       <a:r>
-                        <a:rPr lang="en-US" sz="2700" dirty="0" spc="2" kern="0">
+                        <a:rPr lang="en-US" sz="2700" dirty="0" spc="-1" kern="0">
                           <a:solidFill>
                             <a:srgbClr val="14161C"/>
                           </a:solidFill>
@@ -4494,10 +4505,10 @@
                           <a:ea typeface="Be Vietnam Pro" pitchFamily="34" charset="-122"/>
                           <a:cs typeface="Be Vietnam Pro" pitchFamily="34" charset="-120"/>
                         </a:rPr>
-                        <a:t>Lưu</a:t>
+                        <a:t>Chìa</a:t>
                       </a:r>
                       <a:r>
-                        <a:rPr lang="en-US" sz="2700" dirty="0" spc="-40" kern="0">
+                        <a:rPr lang="en-US" sz="2700" dirty="0" spc="-5" kern="0">
                           <a:solidFill>
                             <a:srgbClr val="14161C"/>
                           </a:solidFill>
@@ -4505,10 +4516,10 @@
                           <a:ea typeface="Be Vietnam Pro" pitchFamily="34" charset="-122"/>
                           <a:cs typeface="Be Vietnam Pro" pitchFamily="34" charset="-120"/>
                         </a:rPr>
-                        <a:t> ra</a:t>
+                        <a:t> khóa</a:t>
                       </a:r>
                       <a:r>
-                        <a:rPr lang="en-US" sz="2700" dirty="0" spc="-9" kern="0">
+                        <a:rPr lang="en-US" sz="2700" dirty="0" spc="-1" kern="0">
                           <a:solidFill>
                             <a:srgbClr val="14161C"/>
                           </a:solidFill>
@@ -4516,7 +4527,18 @@
                           <a:ea typeface="Be Vietnam Pro" pitchFamily="34" charset="-122"/>
                           <a:cs typeface="Be Vietnam Pro" pitchFamily="34" charset="-120"/>
                         </a:rPr>
-                        <a:t> sao?</a:t>
+                        <a:t> giải</a:t>
+                      </a:r>
+                      <a:r>
+                        <a:rPr lang="en-US" sz="2700" dirty="0" spc="-2" kern="0">
+                          <a:solidFill>
+                            <a:srgbClr val="14161C"/>
+                          </a:solidFill>
+                          <a:latin typeface="Be Vietnam Pro" pitchFamily="34" charset="0"/>
+                          <a:ea typeface="Be Vietnam Pro" pitchFamily="34" charset="-122"/>
+                          <a:cs typeface="Be Vietnam Pro" pitchFamily="34" charset="-120"/>
+                        </a:rPr>
+                        <a:t> mã?</a:t>
                       </a:r>
                       <a:endParaRPr lang="en-US" sz="1200" dirty="0"/>
                     </a:p>
@@ -4574,7 +4596,7 @@
                         <a:t>Chia</a:t>
                       </a:r>
                       <a:r>
-                        <a:rPr lang="en-US" sz="2700" dirty="0" spc="-2" kern="0">
+                        <a:rPr lang="en-US" sz="2700" dirty="0" spc="-1" kern="0">
                           <a:solidFill>
                             <a:srgbClr val="14161C"/>
                           </a:solidFill>
@@ -4582,21 +4604,10 @@
                           <a:ea typeface="Be Vietnam Pro" pitchFamily="34" charset="-122"/>
                           <a:cs typeface="Be Vietnam Pro" pitchFamily="34" charset="-120"/>
                         </a:rPr>
-                        <a:t> nhiều</a:t>
+                        <a:t> phần,</a:t>
                       </a:r>
                       <a:r>
-                        <a:rPr lang="en-US" sz="2700" dirty="0" spc="0" kern="0">
-                          <a:solidFill>
-                            <a:srgbClr val="14161C"/>
-                          </a:solidFill>
-                          <a:latin typeface="Be Vietnam Pro" pitchFamily="34" charset="0"/>
-                          <a:ea typeface="Be Vietnam Pro" pitchFamily="34" charset="-122"/>
-                          <a:cs typeface="Be Vietnam Pro" pitchFamily="34" charset="-120"/>
-                        </a:rPr>
-                        <a:t> mảnh,</a:t>
-                      </a:r>
-                      <a:r>
-                        <a:rPr lang="en-US" sz="2700" dirty="0" spc="-12" kern="0">
+                        <a:rPr lang="en-US" sz="2700" dirty="0" spc="-11" kern="0">
                           <a:solidFill>
                             <a:srgbClr val="14161C"/>
                           </a:solidFill>
@@ -4626,18 +4637,7 @@
                           <a:ea typeface="Be Vietnam Pro" pitchFamily="34" charset="-122"/>
                           <a:cs typeface="Be Vietnam Pro" pitchFamily="34" charset="-120"/>
                         </a:rPr>
-                        <a:t> nhiều</a:t>
-                      </a:r>
-                      <a:r>
-                        <a:rPr lang="en-US" sz="2700" dirty="0" spc="9" kern="0">
-                          <a:solidFill>
-                            <a:srgbClr val="14161C"/>
-                          </a:solidFill>
-                          <a:latin typeface="Be Vietnam Pro" pitchFamily="34" charset="0"/>
-                          <a:ea typeface="Be Vietnam Pro" pitchFamily="34" charset="-122"/>
-                          <a:cs typeface="Be Vietnam Pro" pitchFamily="34" charset="-120"/>
-                        </a:rPr>
-                        <a:t> nước</a:t>
+                        <a:t> nhiều nơi</a:t>
                       </a:r>
                       <a:endParaRPr lang="en-US" sz="1200" dirty="0"/>
                     </a:p>
@@ -5337,7 +5337,7 @@
               <a:buNone/>
             </a:pPr>
             <a:r>
-              <a:rPr lang="en-US" sz="6900" dirty="0" spc="-9" kern="0">
+              <a:rPr lang="en-US" sz="6900" dirty="0" spc="-14" kern="0">
                 <a:solidFill>
                   <a:srgbClr val="F3EEE3"/>
                 </a:solidFill>
@@ -5345,10 +5345,10 @@
                 <a:ea typeface="Bricolage Grotesque ExtraBold" pitchFamily="34" charset="-122"/>
                 <a:cs typeface="Bricolage Grotesque ExtraBold" pitchFamily="34" charset="-120"/>
               </a:rPr>
-              <a:t>Khóa</a:t>
-            </a:r>
-            <a:r>
-              <a:rPr lang="en-US" sz="6900" dirty="0" spc="1" kern="0">
+              <a:t>Chìa</a:t>
+            </a:r>
+            <a:r>
+              <a:rPr lang="en-US" sz="6900" dirty="0" spc="-8" kern="0">
                 <a:solidFill>
                   <a:srgbClr val="F3EEE3"/>
                 </a:solidFill>
@@ -5356,10 +5356,10 @@
                 <a:ea typeface="Bricolage Grotesque ExtraBold" pitchFamily="34" charset="-122"/>
                 <a:cs typeface="Bricolage Grotesque ExtraBold" pitchFamily="34" charset="-120"/>
               </a:rPr>
-              <a:t> cũng</a:t>
-            </a:r>
-            <a:r>
-              <a:rPr lang="en-US" sz="6900" dirty="0" spc="0" kern="0">
+              <a:t> khóa</a:t>
+            </a:r>
+            <a:r>
+              <a:rPr lang="en-US" sz="6900" dirty="0" spc="-33" kern="0">
                 <a:solidFill>
                   <a:srgbClr val="F3EEE3"/>
                 </a:solidFill>
@@ -5367,10 +5367,10 @@
                 <a:ea typeface="Bricolage Grotesque ExtraBold" pitchFamily="34" charset="-122"/>
                 <a:cs typeface="Bricolage Grotesque ExtraBold" pitchFamily="34" charset="-120"/>
               </a:rPr>
-              <a:t> bị</a:t>
-            </a:r>
-            <a:r>
-              <a:rPr lang="en-US" sz="6900" dirty="0" spc="-1" kern="0">
+              <a:t> mới</a:t>
+            </a:r>
+            <a:r>
+              <a:rPr lang="en-US" sz="6900" dirty="0" spc="0" kern="0">
                 <a:solidFill>
                   <a:srgbClr val="F3EEE3"/>
                 </a:solidFill>
@@ -5378,10 +5378,10 @@
                 <a:ea typeface="Bricolage Grotesque ExtraBold" pitchFamily="34" charset="-122"/>
                 <a:cs typeface="Bricolage Grotesque ExtraBold" pitchFamily="34" charset="-120"/>
               </a:rPr>
-              <a:t> chia</a:t>
-            </a:r>
-            <a:r>
-              <a:rPr lang="en-US" sz="6900" dirty="0" spc="2" kern="0">
+              <a:t> bị</a:t>
+            </a:r>
+            <a:r>
+              <a:rPr lang="en-US" sz="6900" dirty="0" spc="-1" kern="0">
                 <a:solidFill>
                   <a:srgbClr val="F3EEE3"/>
                 </a:solidFill>
@@ -5389,7 +5389,18 @@
                 <a:ea typeface="Bricolage Grotesque ExtraBold" pitchFamily="34" charset="-122"/>
                 <a:cs typeface="Bricolage Grotesque ExtraBold" pitchFamily="34" charset="-120"/>
               </a:rPr>
-              <a:t> nhỏ</a:t>
+              <a:t> chia</a:t>
+            </a:r>
+            <a:r>
+              <a:rPr lang="en-US" sz="6900" dirty="0" spc="3" kern="0">
+                <a:solidFill>
+                  <a:srgbClr val="F3EEE3"/>
+                </a:solidFill>
+                <a:latin typeface="Bricolage Grotesque ExtraBold" pitchFamily="34" charset="0"/>
+                <a:ea typeface="Bricolage Grotesque ExtraBold" pitchFamily="34" charset="-122"/>
+                <a:cs typeface="Bricolage Grotesque ExtraBold" pitchFamily="34" charset="-120"/>
+              </a:rPr>
+              <a:t> phần</a:t>
             </a:r>
             <a:endParaRPr lang="en-US" sz="6900" dirty="0"/>
           </a:p>
@@ -5455,10 +5466,10 @@
                 <a:ea typeface="Be Vietnam Pro" pitchFamily="34" charset="-122"/>
                 <a:cs typeface="Be Vietnam Pro" pitchFamily="34" charset="-120"/>
               </a:rPr>
-              <a:t>MỌI</a:t>
-            </a:r>
-            <a:r>
-              <a:rPr lang="en-US" sz="1950" b="1" spc="223" kern="0" dirty="0">
+              <a:t>TIN</a:t>
+            </a:r>
+            <a:r>
+              <a:rPr lang="en-US" sz="1950" b="1" spc="200" kern="0" dirty="0">
                 <a:solidFill>
                   <a:srgbClr val="7C93FF"/>
                 </a:solidFill>
@@ -5466,10 +5477,10 @@
                 <a:ea typeface="Be Vietnam Pro" pitchFamily="34" charset="-122"/>
                 <a:cs typeface="Be Vietnam Pro" pitchFamily="34" charset="-120"/>
               </a:rPr>
-              <a:t> MẢNH</a:t>
-            </a:r>
-            <a:r>
-              <a:rPr lang="en-US" sz="1950" b="1" spc="225" kern="0" dirty="0">
+              <a:t> ĐÃ</a:t>
+            </a:r>
+            <a:r>
+              <a:rPr lang="en-US" sz="1950" b="1" spc="222" kern="0" dirty="0">
                 <a:solidFill>
                   <a:srgbClr val="7C93FF"/>
                 </a:solidFill>
@@ -5477,7 +5488,18 @@
                 <a:ea typeface="Be Vietnam Pro" pitchFamily="34" charset="-122"/>
                 <a:cs typeface="Be Vietnam Pro" pitchFamily="34" charset="-120"/>
               </a:rPr>
-              <a:t> TIN</a:t>
+              <a:t> MÃ</a:t>
+            </a:r>
+            <a:r>
+              <a:rPr lang="en-US" sz="1950" b="1" spc="206" kern="0" dirty="0">
+                <a:solidFill>
+                  <a:srgbClr val="7C93FF"/>
+                </a:solidFill>
+                <a:latin typeface="Be Vietnam Pro" pitchFamily="34" charset="0"/>
+                <a:ea typeface="Be Vietnam Pro" pitchFamily="34" charset="-122"/>
+                <a:cs typeface="Be Vietnam Pro" pitchFamily="34" charset="-120"/>
+              </a:rPr>
+              <a:t> HÓA</a:t>
             </a:r>
             <a:endParaRPr lang="en-US" sz="1950" dirty="0"/>
           </a:p>
@@ -5511,7 +5533,7 @@
               <a:buNone/>
             </a:pPr>
             <a:r>
-              <a:rPr lang="en-US" sz="2550" dirty="0" spc="-15" kern="0">
+              <a:rPr lang="en-US" sz="2550" dirty="0" spc="25" kern="0">
                 <a:solidFill>
                   <a:srgbClr val="E4E1D8"/>
                 </a:solidFill>
@@ -5519,7 +5541,7 @@
                 <a:ea typeface="Be Vietnam Pro" pitchFamily="34" charset="-122"/>
                 <a:cs typeface="Be Vietnam Pro" pitchFamily="34" charset="-120"/>
               </a:rPr>
-              <a:t>cất</a:t>
+              <a:t>lưu</a:t>
             </a:r>
             <a:r>
               <a:rPr lang="en-US" sz="2550" dirty="0" spc="0" kern="0">
@@ -5541,10 +5563,10 @@
                 <a:ea typeface="Be Vietnam Pro" pitchFamily="34" charset="-122"/>
                 <a:cs typeface="Be Vietnam Pro" pitchFamily="34" charset="-120"/>
               </a:rPr>
-              <a:t> nhiều</a:t>
-            </a:r>
-            <a:r>
-              <a:rPr lang="en-US" sz="2550" dirty="0" spc="6" kern="0">
+              <a:t> nhiều trung</a:t>
+            </a:r>
+            <a:r>
+              <a:rPr lang="en-US" sz="2550" dirty="0" spc="-11" kern="0">
                 <a:solidFill>
                   <a:srgbClr val="E4E1D8"/>
                 </a:solidFill>
@@ -5552,7 +5574,18 @@
                 <a:ea typeface="Be Vietnam Pro" pitchFamily="34" charset="-122"/>
                 <a:cs typeface="Be Vietnam Pro" pitchFamily="34" charset="-120"/>
               </a:rPr>
-              <a:t> nước</a:t>
+              <a:t> tâm</a:t>
+            </a:r>
+            <a:r>
+              <a:rPr lang="en-US" sz="2550" dirty="0" spc="-1" kern="0">
+                <a:solidFill>
+                  <a:srgbClr val="E4E1D8"/>
+                </a:solidFill>
+                <a:latin typeface="Be Vietnam Pro" pitchFamily="34" charset="0"/>
+                <a:ea typeface="Be Vietnam Pro" pitchFamily="34" charset="-122"/>
+                <a:cs typeface="Be Vietnam Pro" pitchFamily="34" charset="-120"/>
+              </a:rPr>
+              <a:t> dữ</a:t>
             </a:r>
             <a:r>
               <a:rPr lang="en-US" sz="2550" dirty="0" spc="1" kern="0">
@@ -5563,18 +5596,7 @@
                 <a:ea typeface="Be Vietnam Pro" pitchFamily="34" charset="-122"/>
                 <a:cs typeface="Be Vietnam Pro" pitchFamily="34" charset="-120"/>
               </a:rPr>
-              <a:t> khác</a:t>
-            </a:r>
-            <a:r>
-              <a:rPr lang="en-US" sz="2550" dirty="0" spc="0" kern="0">
-                <a:solidFill>
-                  <a:srgbClr val="E4E1D8"/>
-                </a:solidFill>
-                <a:latin typeface="Be Vietnam Pro" pitchFamily="34" charset="0"/>
-                <a:ea typeface="Be Vietnam Pro" pitchFamily="34" charset="-122"/>
-                <a:cs typeface="Be Vietnam Pro" pitchFamily="34" charset="-120"/>
-              </a:rPr>
-              <a:t> nhau</a:t>
+              <a:t> liệu</a:t>
             </a:r>
             <a:endParaRPr lang="en-US" sz="2550" dirty="0"/>
           </a:p>
@@ -5632,7 +5654,7 @@
               <a:buNone/>
             </a:pPr>
             <a:r>
-              <a:rPr lang="en-US" sz="1950" b="1" spc="225" kern="0" dirty="0">
+              <a:rPr lang="en-US" sz="1950" b="1" spc="226" kern="0" dirty="0">
                 <a:solidFill>
                   <a:srgbClr val="FFB454"/>
                 </a:solidFill>
@@ -5640,10 +5662,10 @@
                 <a:ea typeface="Be Vietnam Pro" pitchFamily="34" charset="-122"/>
                 <a:cs typeface="Be Vietnam Pro" pitchFamily="34" charset="-120"/>
               </a:rPr>
-              <a:t>MỌI</a:t>
-            </a:r>
-            <a:r>
-              <a:rPr lang="en-US" sz="1950" b="1" spc="223" kern="0" dirty="0">
+              <a:t>CHÌA</a:t>
+            </a:r>
+            <a:r>
+              <a:rPr lang="en-US" sz="1950" b="1" spc="209" kern="0" dirty="0">
                 <a:solidFill>
                   <a:srgbClr val="FFB454"/>
                 </a:solidFill>
@@ -5651,10 +5673,10 @@
                 <a:ea typeface="Be Vietnam Pro" pitchFamily="34" charset="-122"/>
                 <a:cs typeface="Be Vietnam Pro" pitchFamily="34" charset="-120"/>
               </a:rPr>
-              <a:t> MẢNH</a:t>
-            </a:r>
-            <a:r>
-              <a:rPr lang="en-US" sz="1950" b="1" spc="226" kern="0" dirty="0">
+              <a:t> KHÓA</a:t>
+            </a:r>
+            <a:r>
+              <a:rPr lang="en-US" sz="1950" b="1" spc="227" kern="0" dirty="0">
                 <a:solidFill>
                   <a:srgbClr val="FFB454"/>
                 </a:solidFill>
@@ -5662,10 +5684,10 @@
                 <a:ea typeface="Be Vietnam Pro" pitchFamily="34" charset="-122"/>
                 <a:cs typeface="Be Vietnam Pro" pitchFamily="34" charset="-120"/>
               </a:rPr>
-              <a:t> CHÌA</a:t>
-            </a:r>
-            <a:r>
-              <a:rPr lang="en-US" sz="1950" b="1" spc="209" kern="0" dirty="0">
+              <a:t> GIẢI</a:t>
+            </a:r>
+            <a:r>
+              <a:rPr lang="en-US" sz="1950" b="1" spc="222" kern="0" dirty="0">
                 <a:solidFill>
                   <a:srgbClr val="FFB454"/>
                 </a:solidFill>
@@ -5673,7 +5695,7 @@
                 <a:ea typeface="Be Vietnam Pro" pitchFamily="34" charset="-122"/>
                 <a:cs typeface="Be Vietnam Pro" pitchFamily="34" charset="-120"/>
               </a:rPr>
-              <a:t> KHÓA</a:t>
+              <a:t> MÃ</a:t>
             </a:r>
             <a:endParaRPr lang="en-US" sz="1950" dirty="0"/>
           </a:p>
@@ -5715,10 +5737,10 @@
                 <a:ea typeface="Be Vietnam Pro" pitchFamily="34" charset="-122"/>
                 <a:cs typeface="Be Vietnam Pro" pitchFamily="34" charset="-120"/>
               </a:rPr>
-              <a:t>cũng</a:t>
-            </a:r>
-            <a:r>
-              <a:rPr lang="en-US" sz="2550" dirty="0" spc="-11" kern="0">
+              <a:t>chia</a:t>
+            </a:r>
+            <a:r>
+              <a:rPr lang="en-US" sz="2550" dirty="0" spc="0" kern="0">
                 <a:solidFill>
                   <a:srgbClr val="E4E1D8"/>
                 </a:solidFill>
@@ -5726,9 +5748,31 @@
                 <a:ea typeface="Be Vietnam Pro" pitchFamily="34" charset="-122"/>
                 <a:cs typeface="Be Vietnam Pro" pitchFamily="34" charset="-120"/>
               </a:rPr>
+              <a:t> phần,</a:t>
+            </a:r>
+            <a:r>
+              <a:rPr lang="en-US" sz="2550" dirty="0" spc="-12" kern="0">
+                <a:solidFill>
+                  <a:srgbClr val="E4E1D8"/>
+                </a:solidFill>
+                <a:latin typeface="Be Vietnam Pro" pitchFamily="34" charset="0"/>
+                <a:ea typeface="Be Vietnam Pro" pitchFamily="34" charset="-122"/>
+                <a:cs typeface="Be Vietnam Pro" pitchFamily="34" charset="-120"/>
+              </a:rPr>
               <a:t> cất</a:t>
             </a:r>
             <a:r>
+              <a:rPr lang="en-US" sz="2550" dirty="0" spc="1" kern="0">
+                <a:solidFill>
+                  <a:srgbClr val="E4E1D8"/>
+                </a:solidFill>
+                <a:latin typeface="Be Vietnam Pro" pitchFamily="34" charset="0"/>
+                <a:ea typeface="Be Vietnam Pro" pitchFamily="34" charset="-122"/>
+                <a:cs typeface="Be Vietnam Pro" pitchFamily="34" charset="-120"/>
+              </a:rPr>
+              <a:t> nhiều</a:t>
+            </a:r>
+            <a:r>
               <a:rPr lang="en-US" sz="2550" dirty="0" spc="-1" kern="0">
                 <a:solidFill>
                   <a:srgbClr val="E4E1D8"/>
@@ -5737,29 +5781,7 @@
                 <a:ea typeface="Be Vietnam Pro" pitchFamily="34" charset="-122"/>
                 <a:cs typeface="Be Vietnam Pro" pitchFamily="34" charset="-120"/>
               </a:rPr>
-              <a:t> ở</a:t>
-            </a:r>
-            <a:r>
-              <a:rPr lang="en-US" sz="2550" dirty="0" spc="1" kern="0">
-                <a:solidFill>
-                  <a:srgbClr val="E4E1D8"/>
-                </a:solidFill>
-                <a:latin typeface="Be Vietnam Pro" pitchFamily="34" charset="0"/>
-                <a:ea typeface="Be Vietnam Pro" pitchFamily="34" charset="-122"/>
-                <a:cs typeface="Be Vietnam Pro" pitchFamily="34" charset="-120"/>
-              </a:rPr>
-              <a:t> nhiều</a:t>
-            </a:r>
-            <a:r>
-              <a:rPr lang="en-US" sz="2550" dirty="0" spc="6" kern="0">
-                <a:solidFill>
-                  <a:srgbClr val="E4E1D8"/>
-                </a:solidFill>
-                <a:latin typeface="Be Vietnam Pro" pitchFamily="34" charset="0"/>
-                <a:ea typeface="Be Vietnam Pro" pitchFamily="34" charset="-122"/>
-                <a:cs typeface="Be Vietnam Pro" pitchFamily="34" charset="-120"/>
-              </a:rPr>
-              <a:t> nước</a:t>
+              <a:t> nơi</a:t>
             </a:r>
             <a:endParaRPr lang="en-US" sz="2550" dirty="0"/>
           </a:p>
@@ -5862,7 +5884,7 @@
               <a:buNone/>
             </a:pPr>
             <a:r>
-              <a:rPr lang="en-US" sz="1950" b="1" spc="222" kern="0" dirty="0">
+              <a:rPr lang="en-US" sz="1950" b="1" spc="226" kern="0" dirty="0">
                 <a:solidFill>
                   <a:srgbClr val="14161C"/>
                 </a:solidFill>
@@ -5870,10 +5892,10 @@
                 <a:ea typeface="Be Vietnam Pro" pitchFamily="34" charset="-122"/>
                 <a:cs typeface="Be Vietnam Pro" pitchFamily="34" charset="-120"/>
               </a:rPr>
-              <a:t>KẺ</a:t>
-            </a:r>
-            <a:r>
-              <a:rPr lang="en-US" sz="1950" b="1" spc="176" kern="0" dirty="0">
+              <a:t>PHẢI</a:t>
+            </a:r>
+            <a:r>
+              <a:rPr lang="en-US" sz="1950" b="1" spc="224" kern="0" dirty="0">
                 <a:solidFill>
                   <a:srgbClr val="14161C"/>
                 </a:solidFill>
@@ -5881,10 +5903,10 @@
                 <a:ea typeface="Be Vietnam Pro" pitchFamily="34" charset="-122"/>
                 <a:cs typeface="Be Vietnam Pro" pitchFamily="34" charset="-120"/>
               </a:rPr>
-              <a:t> TẤN</a:t>
-            </a:r>
-            <a:r>
-              <a:rPr lang="en-US" sz="1950" b="1" spc="225" kern="0" dirty="0">
+              <a:t> GOM</a:t>
+            </a:r>
+            <a:r>
+              <a:rPr lang="en-US" sz="1950" b="1" spc="228" kern="0" dirty="0">
                 <a:solidFill>
                   <a:srgbClr val="14161C"/>
                 </a:solidFill>
@@ -5892,7 +5914,7 @@
                 <a:ea typeface="Be Vietnam Pro" pitchFamily="34" charset="-122"/>
                 <a:cs typeface="Be Vietnam Pro" pitchFamily="34" charset="-120"/>
               </a:rPr>
-              <a:t> CÔNG PHẢI</a:t>
+              <a:t> ĐỦ</a:t>
             </a:r>
             <a:r>
               <a:rPr lang="en-US" sz="1950" b="1" spc="224" kern="0" dirty="0">
@@ -5903,10 +5925,10 @@
                 <a:ea typeface="Be Vietnam Pro" pitchFamily="34" charset="-122"/>
                 <a:cs typeface="Be Vietnam Pro" pitchFamily="34" charset="-120"/>
               </a:rPr>
-              <a:t> CÓ</a:t>
-            </a:r>
-            <a:r>
-              <a:rPr lang="en-US" sz="1950" b="1" spc="197" kern="0" dirty="0">
+              <a:t> PHẦN</a:t>
+            </a:r>
+            <a:r>
+              <a:rPr lang="en-US" sz="1950" b="1" spc="226" kern="0" dirty="0">
                 <a:solidFill>
                   <a:srgbClr val="14161C"/>
                 </a:solidFill>
@@ -5914,10 +5936,10 @@
                 <a:ea typeface="Be Vietnam Pro" pitchFamily="34" charset="-122"/>
                 <a:cs typeface="Be Vietnam Pro" pitchFamily="34" charset="-120"/>
               </a:rPr>
-              <a:t> CẢ</a:t>
-            </a:r>
-            <a:r>
-              <a:rPr lang="en-US" sz="1950" b="1" spc="226" kern="0" dirty="0">
+              <a:t> CHÌA</a:t>
+            </a:r>
+            <a:r>
+              <a:rPr lang="en-US" sz="1950" b="1" spc="209" kern="0" dirty="0">
                 <a:solidFill>
                   <a:srgbClr val="14161C"/>
                 </a:solidFill>
@@ -5925,7 +5947,7 @@
                 <a:ea typeface="Be Vietnam Pro" pitchFamily="34" charset="-122"/>
                 <a:cs typeface="Be Vietnam Pro" pitchFamily="34" charset="-120"/>
               </a:rPr>
-              <a:t> HAI</a:t>
+              <a:t> KHÓA</a:t>
             </a:r>
             <a:endParaRPr lang="en-US" sz="1950" dirty="0"/>
           </a:p>
@@ -9251,7 +9273,7 @@
               <a:buChar char="•"/>
             </a:pPr>
             <a:r>
-              <a:rPr lang="en-US" sz="2550" dirty="0" spc="-3" kern="0">
+              <a:rPr lang="en-US" sz="2550" dirty="0" spc="1" kern="0">
                 <a:solidFill>
                   <a:srgbClr val="14161C"/>
                 </a:solidFill>
@@ -9259,10 +9281,10 @@
                 <a:ea typeface="Be Vietnam Pro" pitchFamily="34" charset="-122"/>
                 <a:cs typeface="Be Vietnam Pro" pitchFamily="34" charset="-120"/>
               </a:rPr>
-              <a:t>Tin</a:t>
-            </a:r>
-            <a:r>
-              <a:rPr lang="en-US" sz="2550" dirty="0" spc="-18" kern="0">
+              <a:t>Chìa</a:t>
+            </a:r>
+            <a:r>
+              <a:rPr lang="en-US" sz="2550" dirty="0" spc="-2" kern="0">
                 <a:solidFill>
                   <a:srgbClr val="14161C"/>
                 </a:solidFill>
@@ -9270,10 +9292,10 @@
                 <a:ea typeface="Be Vietnam Pro" pitchFamily="34" charset="-122"/>
                 <a:cs typeface="Be Vietnam Pro" pitchFamily="34" charset="-120"/>
               </a:rPr>
-              <a:t> và</a:t>
-            </a:r>
-            <a:r>
-              <a:rPr lang="en-US" sz="2550" dirty="0" spc="-3" kern="0">
+              <a:t> khóa</a:t>
+            </a:r>
+            <a:r>
+              <a:rPr lang="en-US" sz="2550" dirty="0" spc="-1" kern="0">
                 <a:solidFill>
                   <a:srgbClr val="14161C"/>
                 </a:solidFill>
@@ -9281,10 +9303,10 @@
                 <a:ea typeface="Be Vietnam Pro" pitchFamily="34" charset="-122"/>
                 <a:cs typeface="Be Vietnam Pro" pitchFamily="34" charset="-120"/>
               </a:rPr>
-              <a:t> khóa</a:t>
-            </a:r>
-            <a:r>
-              <a:rPr lang="en-US" sz="2550" dirty="0" spc="0" kern="0">
+              <a:t> chia phần,</a:t>
+            </a:r>
+            <a:r>
+              <a:rPr lang="en-US" sz="2550" dirty="0" spc="-11" kern="0">
                 <a:solidFill>
                   <a:srgbClr val="14161C"/>
                 </a:solidFill>
@@ -9292,10 +9314,10 @@
                 <a:ea typeface="Be Vietnam Pro" pitchFamily="34" charset="-122"/>
                 <a:cs typeface="Be Vietnam Pro" pitchFamily="34" charset="-120"/>
               </a:rPr>
-              <a:t> chia</a:t>
-            </a:r>
-            <a:r>
-              <a:rPr lang="en-US" sz="2550" dirty="0" spc="-35" kern="0">
+              <a:t> cất</a:t>
+            </a:r>
+            <a:r>
+              <a:rPr lang="en-US" sz="2550" dirty="0" spc="-1" kern="0">
                 <a:solidFill>
                   <a:srgbClr val="14161C"/>
                 </a:solidFill>
@@ -9303,10 +9325,10 @@
                 <a:ea typeface="Be Vietnam Pro" pitchFamily="34" charset="-122"/>
                 <a:cs typeface="Be Vietnam Pro" pitchFamily="34" charset="-120"/>
               </a:rPr>
-              <a:t> ra</a:t>
-            </a:r>
-            <a:r>
-              <a:rPr lang="en-US" sz="2550" dirty="0" spc="1" kern="0">
+              <a:t> nơi</a:t>
+            </a:r>
+            <a:r>
+              <a:rPr lang="en-US" sz="2550" dirty="0" spc="2" kern="0">
                 <a:solidFill>
                   <a:srgbClr val="14161C"/>
                 </a:solidFill>
@@ -9314,18 +9336,7 @@
                 <a:ea typeface="Be Vietnam Pro" pitchFamily="34" charset="-122"/>
                 <a:cs typeface="Be Vietnam Pro" pitchFamily="34" charset="-120"/>
               </a:rPr>
-              <a:t> nhiều</a:t>
-            </a:r>
-            <a:r>
-              <a:rPr lang="en-US" sz="2550" dirty="0" spc="5" kern="0">
-                <a:solidFill>
-                  <a:srgbClr val="14161C"/>
-                </a:solidFill>
-                <a:latin typeface="Be Vietnam Pro" pitchFamily="34" charset="0"/>
-                <a:ea typeface="Be Vietnam Pro" pitchFamily="34" charset="-122"/>
-                <a:cs typeface="Be Vietnam Pro" pitchFamily="34" charset="-120"/>
-              </a:rPr>
-              <a:t> nước.</a:t>
+              <a:t> khác.</a:t>
             </a:r>
             <a:endParaRPr lang="en-US" sz="2550" dirty="0"/>
           </a:p>
@@ -9350,7 +9361,7 @@
               <a:t>Còn phải</a:t>
             </a:r>
             <a:r>
-              <a:rPr lang="en-US" sz="2550" dirty="0" spc="-10" kern="0">
+              <a:rPr lang="en-US" sz="2550" dirty="0" spc="-12" kern="0">
                 <a:solidFill>
                   <a:srgbClr val="14161C"/>
                 </a:solidFill>
@@ -9358,7 +9369,18 @@
                 <a:ea typeface="Be Vietnam Pro" pitchFamily="34" charset="-122"/>
                 <a:cs typeface="Be Vietnam Pro" pitchFamily="34" charset="-120"/>
               </a:rPr>
-              <a:t> lấy</a:t>
+              <a:t> gom</a:t>
+            </a:r>
+            <a:r>
+              <a:rPr lang="en-US" sz="2550" dirty="0" spc="-2" kern="0">
+                <a:solidFill>
+                  <a:srgbClr val="14161C"/>
+                </a:solidFill>
+                <a:latin typeface="Be Vietnam Pro" pitchFamily="34" charset="0"/>
+                <a:ea typeface="Be Vietnam Pro" pitchFamily="34" charset="-122"/>
+                <a:cs typeface="Be Vietnam Pro" pitchFamily="34" charset="-120"/>
+              </a:rPr>
+              <a:t> đủ</a:t>
             </a:r>
             <a:r>
               <a:rPr lang="en-US" sz="2550" dirty="0" spc="1" kern="0">
@@ -9369,7 +9391,18 @@
                 <a:ea typeface="Be Vietnam Pro" pitchFamily="34" charset="-122"/>
                 <a:cs typeface="Be Vietnam Pro" pitchFamily="34" charset="-120"/>
               </a:rPr>
-              <a:t> mảnh</a:t>
+              <a:t> các</a:t>
+            </a:r>
+            <a:r>
+              <a:rPr lang="en-US" sz="2550" dirty="0" spc="0" kern="0">
+                <a:solidFill>
+                  <a:srgbClr val="14161C"/>
+                </a:solidFill>
+                <a:latin typeface="Be Vietnam Pro" pitchFamily="34" charset="0"/>
+                <a:ea typeface="Be Vietnam Pro" pitchFamily="34" charset="-122"/>
+                <a:cs typeface="Be Vietnam Pro" pitchFamily="34" charset="-120"/>
+              </a:rPr>
+              <a:t> phần chìa</a:t>
             </a:r>
             <a:r>
               <a:rPr lang="en-US" sz="2550" dirty="0" spc="-1" kern="0">
@@ -9380,18 +9413,7 @@
                 <a:ea typeface="Be Vietnam Pro" pitchFamily="34" charset="-122"/>
                 <a:cs typeface="Be Vietnam Pro" pitchFamily="34" charset="-120"/>
               </a:rPr>
-              <a:t> ở nơi</a:t>
-            </a:r>
-            <a:r>
-              <a:rPr lang="en-US" sz="2550" dirty="0" spc="1" kern="0">
-                <a:solidFill>
-                  <a:srgbClr val="14161C"/>
-                </a:solidFill>
-                <a:latin typeface="Be Vietnam Pro" pitchFamily="34" charset="0"/>
-                <a:ea typeface="Be Vietnam Pro" pitchFamily="34" charset="-122"/>
-                <a:cs typeface="Be Vietnam Pro" pitchFamily="34" charset="-120"/>
-              </a:rPr>
-              <a:t> khác.</a:t>
+              <a:t> khóa.</a:t>
             </a:r>
             <a:endParaRPr lang="en-US" sz="2550" dirty="0"/>
           </a:p>

</xml_diff>

<commit_message>
sd-02-004 cites Telegram's FAQ for the key split; sd-07-009 metadata follows the redrawn figure
Co-Authored-By: Claude Opus 5.5 <noreply@anthropic.com>
Claude-Session: https://claude.ai/code/session_01TDEQZkTojRsEuCWxmNaEbL
</commit_message>
<xml_diff>
--- a/system-design-101/vi/lessons/sd-02-004/slides/sd-02-004.pptx
+++ b/system-design-101/vi/lessons/sd-02-004/slides/sd-02-004.pptx
@@ -12399,7 +12399,7 @@
               <a:t>ByteByteGo</a:t>
             </a:r>
             <a:r>
-              <a:rPr lang="en-US" sz="2550" dirty="0" spc="-9" kern="0">
+              <a:rPr lang="en-US" sz="2550" dirty="0" spc="-12" kern="0">
                 <a:solidFill>
                   <a:srgbClr val="E4E1D8"/>
                 </a:solidFill>
@@ -12407,10 +12407,10 @@
                 <a:ea typeface="Be Vietnam Pro" pitchFamily="34" charset="-122"/>
                 <a:cs typeface="Be Vietnam Pro" pitchFamily="34" charset="-120"/>
               </a:rPr>
-              <a:t> system-design-101,</a:t>
-            </a:r>
-            <a:r>
-              <a:rPr lang="en-US" sz="2550" dirty="0" spc="-4" kern="0">
+              <a:t> tại</a:t>
+            </a:r>
+            <a:r>
+              <a:rPr lang="en-US" sz="2550" dirty="0" spc="1" kern="0">
                 <a:solidFill>
                   <a:srgbClr val="E4E1D8"/>
                 </a:solidFill>
@@ -12418,7 +12418,73 @@
                 <a:ea typeface="Be Vietnam Pro" pitchFamily="34" charset="-122"/>
                 <a:cs typeface="Be Vietnam Pro" pitchFamily="34" charset="-120"/>
               </a:rPr>
-              <a:t> bài</a:t>
+              <a:t> commit</a:t>
+            </a:r>
+            <a:r>
+              <a:rPr lang="en-US" sz="2550" dirty="0" spc="-1" kern="0">
+                <a:solidFill>
+                  <a:srgbClr val="E4E1D8"/>
+                </a:solidFill>
+                <a:latin typeface="Be Vietnam Pro" pitchFamily="34" charset="0"/>
+                <a:ea typeface="Be Vietnam Pro" pitchFamily="34" charset="-122"/>
+                <a:cs typeface="Be Vietnam Pro" pitchFamily="34" charset="-120"/>
+              </a:rPr>
+              <a:t> cố</a:t>
+            </a:r>
+            <a:r>
+              <a:rPr lang="en-US" sz="2550" dirty="0" spc="17" kern="0">
+                <a:solidFill>
+                  <a:srgbClr val="E4E1D8"/>
+                </a:solidFill>
+                <a:latin typeface="Be Vietnam Pro" pitchFamily="34" charset="0"/>
+                <a:ea typeface="Be Vietnam Pro" pitchFamily="34" charset="-122"/>
+                <a:cs typeface="Be Vietnam Pro" pitchFamily="34" charset="-120"/>
+              </a:rPr>
+              <a:t> định;</a:t>
+            </a:r>
+            <a:r>
+              <a:rPr lang="en-US" sz="2550" dirty="0" spc="-77" kern="0">
+                <a:solidFill>
+                  <a:srgbClr val="E4E1D8"/>
+                </a:solidFill>
+                <a:latin typeface="Be Vietnam Pro" pitchFamily="34" charset="0"/>
+                <a:ea typeface="Be Vietnam Pro" pitchFamily="34" charset="-122"/>
+                <a:cs typeface="Be Vietnam Pro" pitchFamily="34" charset="-120"/>
+              </a:rPr>
+              <a:t> FAQ</a:t>
+            </a:r>
+            <a:r>
+              <a:rPr lang="en-US" sz="2550" dirty="0" spc="-2" kern="0">
+                <a:solidFill>
+                  <a:srgbClr val="E4E1D8"/>
+                </a:solidFill>
+                <a:latin typeface="Be Vietnam Pro" pitchFamily="34" charset="0"/>
+                <a:ea typeface="Be Vietnam Pro" pitchFamily="34" charset="-122"/>
+                <a:cs typeface="Be Vietnam Pro" pitchFamily="34" charset="-120"/>
+              </a:rPr>
+              <a:t> của</a:t>
+            </a:r>
+            <a:r>
+              <a:rPr lang="en-US" sz="2550" dirty="0" spc="-38" kern="0">
+                <a:solidFill>
+                  <a:srgbClr val="E4E1D8"/>
+                </a:solidFill>
+                <a:latin typeface="Be Vietnam Pro" pitchFamily="34" charset="0"/>
+                <a:ea typeface="Be Vietnam Pro" pitchFamily="34" charset="-122"/>
+                <a:cs typeface="Be Vietnam Pro" pitchFamily="34" charset="-120"/>
+              </a:rPr>
+              <a:t> Telegram</a:t>
+            </a:r>
+            <a:r>
+              <a:rPr lang="en-US" sz="2550" dirty="0" spc="-18" kern="0">
+                <a:solidFill>
+                  <a:srgbClr val="E4E1D8"/>
+                </a:solidFill>
+                <a:latin typeface="Be Vietnam Pro" pitchFamily="34" charset="0"/>
+                <a:ea typeface="Be Vietnam Pro" pitchFamily="34" charset="-122"/>
+                <a:cs typeface="Be Vietnam Pro" pitchFamily="34" charset="-120"/>
+              </a:rPr>
+              <a:t> về</a:t>
             </a:r>
             <a:r>
               <a:rPr lang="en-US" sz="2550" dirty="0" spc="1" kern="0">
@@ -12429,10 +12495,10 @@
                 <a:ea typeface="Be Vietnam Pro" pitchFamily="34" charset="-122"/>
                 <a:cs typeface="Be Vietnam Pro" pitchFamily="34" charset="-120"/>
               </a:rPr>
-              <a:t> nguồn</a:t>
-            </a:r>
-            <a:r>
-              <a:rPr lang="en-US" sz="2550" dirty="0" spc="-12" kern="0">
+              <a:t> cách</a:t>
+            </a:r>
+            <a:r>
+              <a:rPr lang="en-US" sz="2550" dirty="0" spc="18" kern="0">
                 <a:solidFill>
                   <a:srgbClr val="E4E1D8"/>
                 </a:solidFill>
@@ -12440,7 +12506,18 @@
                 <a:ea typeface="Be Vietnam Pro" pitchFamily="34" charset="-122"/>
                 <a:cs typeface="Be Vietnam Pro" pitchFamily="34" charset="-120"/>
               </a:rPr>
-              <a:t> tại</a:t>
+              <a:t> lưu</a:t>
+            </a:r>
+            <a:r>
+              <a:rPr lang="en-US" sz="2550" dirty="0" spc="-2" kern="0">
+                <a:solidFill>
+                  <a:srgbClr val="E4E1D8"/>
+                </a:solidFill>
+                <a:latin typeface="Be Vietnam Pro" pitchFamily="34" charset="0"/>
+                <a:ea typeface="Be Vietnam Pro" pitchFamily="34" charset="-122"/>
+                <a:cs typeface="Be Vietnam Pro" pitchFamily="34" charset="-120"/>
+              </a:rPr>
+              <a:t> dữ</a:t>
             </a:r>
             <a:r>
               <a:rPr lang="en-US" sz="2550" dirty="0" spc="1" kern="0">
@@ -12451,29 +12528,7 @@
                 <a:ea typeface="Be Vietnam Pro" pitchFamily="34" charset="-122"/>
                 <a:cs typeface="Be Vietnam Pro" pitchFamily="34" charset="-120"/>
               </a:rPr>
-              <a:t> commit</a:t>
-            </a:r>
-            <a:r>
-              <a:rPr lang="en-US" sz="2550" dirty="0" spc="-1" kern="0">
-                <a:solidFill>
-                  <a:srgbClr val="E4E1D8"/>
-                </a:solidFill>
-                <a:latin typeface="Be Vietnam Pro" pitchFamily="34" charset="0"/>
-                <a:ea typeface="Be Vietnam Pro" pitchFamily="34" charset="-122"/>
-                <a:cs typeface="Be Vietnam Pro" pitchFamily="34" charset="-120"/>
-              </a:rPr>
-              <a:t> cố</a:t>
-            </a:r>
-            <a:r>
-              <a:rPr lang="en-US" sz="2550" dirty="0" spc="21" kern="0">
-                <a:solidFill>
-                  <a:srgbClr val="E4E1D8"/>
-                </a:solidFill>
-                <a:latin typeface="Be Vietnam Pro" pitchFamily="34" charset="0"/>
-                <a:ea typeface="Be Vietnam Pro" pitchFamily="34" charset="-122"/>
-                <a:cs typeface="Be Vietnam Pro" pitchFamily="34" charset="-120"/>
-              </a:rPr>
-              <a:t> định</a:t>
+              <a:t> liệu</a:t>
             </a:r>
             <a:endParaRPr lang="en-US" sz="2550" dirty="0"/>
           </a:p>
@@ -12559,7 +12614,7 @@
               <a:t> 2026-10-19.</a:t>
             </a:r>
             <a:r>
-              <a:rPr lang="en-US" sz="1800" dirty="0" spc="-40" kern="0">
+              <a:rPr lang="en-US" sz="1800" dirty="0" spc="-51" kern="0">
                 <a:solidFill>
                   <a:srgbClr val="9AA0B5"/>
                 </a:solidFill>
@@ -12567,7 +12622,73 @@
                 <a:ea typeface="Be Vietnam Pro" pitchFamily="34" charset="-122"/>
                 <a:cs typeface="Be Vietnam Pro" pitchFamily="34" charset="-120"/>
               </a:rPr>
-              <a:t> Tài</a:t>
+              <a:t> FAQ</a:t>
+            </a:r>
+            <a:r>
+              <a:rPr lang="en-US" sz="1800" dirty="0" spc="3" kern="0">
+                <a:solidFill>
+                  <a:srgbClr val="9AA0B5"/>
+                </a:solidFill>
+                <a:latin typeface="Be Vietnam Pro" pitchFamily="34" charset="0"/>
+                <a:ea typeface="Be Vietnam Pro" pitchFamily="34" charset="-122"/>
+                <a:cs typeface="Be Vietnam Pro" pitchFamily="34" charset="-120"/>
+              </a:rPr>
+              <a:t> của</a:t>
+            </a:r>
+            <a:r>
+              <a:rPr lang="en-US" sz="1800" dirty="0" spc="-27" kern="0">
+                <a:solidFill>
+                  <a:srgbClr val="9AA0B5"/>
+                </a:solidFill>
+                <a:latin typeface="Be Vietnam Pro" pitchFamily="34" charset="0"/>
+                <a:ea typeface="Be Vietnam Pro" pitchFamily="34" charset="-122"/>
+                <a:cs typeface="Be Vietnam Pro" pitchFamily="34" charset="-120"/>
+              </a:rPr>
+              <a:t> Telegram</a:t>
+            </a:r>
+            <a:r>
+              <a:rPr lang="en-US" sz="1800" dirty="0" spc="10" kern="0">
+                <a:solidFill>
+                  <a:srgbClr val="9AA0B5"/>
+                </a:solidFill>
+                <a:latin typeface="Be Vietnam Pro" pitchFamily="34" charset="0"/>
+                <a:ea typeface="Be Vietnam Pro" pitchFamily="34" charset="-122"/>
+                <a:cs typeface="Be Vietnam Pro" pitchFamily="34" charset="-120"/>
+              </a:rPr>
+              <a:t> đối</a:t>
+            </a:r>
+            <a:r>
+              <a:rPr lang="en-US" sz="1800" dirty="0" spc="-1" kern="0">
+                <a:solidFill>
+                  <a:srgbClr val="9AA0B5"/>
+                </a:solidFill>
+                <a:latin typeface="Be Vietnam Pro" pitchFamily="34" charset="0"/>
+                <a:ea typeface="Be Vietnam Pro" pitchFamily="34" charset="-122"/>
+                <a:cs typeface="Be Vietnam Pro" pitchFamily="34" charset="-120"/>
+              </a:rPr>
+              <a:t> chiếu</a:t>
+            </a:r>
+            <a:r>
+              <a:rPr lang="en-US" sz="1800" dirty="0" spc="0" kern="0">
+                <a:solidFill>
+                  <a:srgbClr val="9AA0B5"/>
+                </a:solidFill>
+                <a:latin typeface="Be Vietnam Pro" pitchFamily="34" charset="0"/>
+                <a:ea typeface="Be Vietnam Pro" pitchFamily="34" charset="-122"/>
+                <a:cs typeface="Be Vietnam Pro" pitchFamily="34" charset="-120"/>
+              </a:rPr>
+              <a:t> qua</a:t>
+            </a:r>
+            <a:r>
+              <a:rPr lang="en-US" sz="1800" dirty="0" spc="-3" kern="0">
+                <a:solidFill>
+                  <a:srgbClr val="9AA0B5"/>
+                </a:solidFill>
+                <a:latin typeface="Be Vietnam Pro" pitchFamily="34" charset="0"/>
+                <a:ea typeface="Be Vietnam Pro" pitchFamily="34" charset="-122"/>
+                <a:cs typeface="Be Vietnam Pro" pitchFamily="34" charset="-120"/>
+              </a:rPr>
+              <a:t> bản</a:t>
             </a:r>
             <a:r>
               <a:rPr lang="en-US" sz="1800" dirty="0" spc="-2" kern="0">
@@ -12578,7 +12699,18 @@
                 <a:ea typeface="Be Vietnam Pro" pitchFamily="34" charset="-122"/>
                 <a:cs typeface="Be Vietnam Pro" pitchFamily="34" charset="-120"/>
               </a:rPr>
-              <a:t> liệu</a:t>
+              <a:t> dẫn</a:t>
+            </a:r>
+            <a:r>
+              <a:rPr lang="en-US" sz="1800" dirty="0" spc="0" kern="0">
+                <a:solidFill>
+                  <a:srgbClr val="9AA0B5"/>
+                </a:solidFill>
+                <a:latin typeface="Be Vietnam Pro" pitchFamily="34" charset="0"/>
+                <a:ea typeface="Be Vietnam Pro" pitchFamily="34" charset="-122"/>
+                <a:cs typeface="Be Vietnam Pro" pitchFamily="34" charset="-120"/>
+              </a:rPr>
+              <a:t> lại</a:t>
             </a:r>
             <a:r>
               <a:rPr lang="en-US" sz="1800" dirty="0" spc="3" kern="0">
@@ -12592,7 +12724,7 @@
               <a:t> của</a:t>
             </a:r>
             <a:r>
-              <a:rPr lang="en-US" sz="1800" dirty="0" spc="-27" kern="0">
+              <a:rPr lang="en-US" sz="1800" dirty="0" spc="-8" kern="0">
                 <a:solidFill>
                   <a:srgbClr val="9AA0B5"/>
                 </a:solidFill>
@@ -12600,40 +12732,7 @@
                 <a:ea typeface="Be Vietnam Pro" pitchFamily="34" charset="-122"/>
                 <a:cs typeface="Be Vietnam Pro" pitchFamily="34" charset="-120"/>
               </a:rPr>
-              <a:t> Telegram</a:t>
-            </a:r>
-            <a:r>
-              <a:rPr lang="en-US" sz="1800" dirty="0" spc="7" kern="0">
-                <a:solidFill>
-                  <a:srgbClr val="9AA0B5"/>
-                </a:solidFill>
-                <a:latin typeface="Be Vietnam Pro" pitchFamily="34" charset="0"/>
-                <a:ea typeface="Be Vietnam Pro" pitchFamily="34" charset="-122"/>
-                <a:cs typeface="Be Vietnam Pro" pitchFamily="34" charset="-120"/>
-              </a:rPr>
-              <a:t> chưa được</a:t>
-            </a:r>
-            <a:r>
-              <a:rPr lang="en-US" sz="1800" dirty="0" spc="10" kern="0">
-                <a:solidFill>
-                  <a:srgbClr val="9AA0B5"/>
-                </a:solidFill>
-                <a:latin typeface="Be Vietnam Pro" pitchFamily="34" charset="0"/>
-                <a:ea typeface="Be Vietnam Pro" pitchFamily="34" charset="-122"/>
-                <a:cs typeface="Be Vietnam Pro" pitchFamily="34" charset="-120"/>
-              </a:rPr>
-              <a:t> đối</a:t>
-            </a:r>
-            <a:r>
-              <a:rPr lang="en-US" sz="1800" dirty="0" spc="-1" kern="0">
-                <a:solidFill>
-                  <a:srgbClr val="9AA0B5"/>
-                </a:solidFill>
-                <a:latin typeface="Be Vietnam Pro" pitchFamily="34" charset="0"/>
-                <a:ea typeface="Be Vietnam Pro" pitchFamily="34" charset="-122"/>
-                <a:cs typeface="Be Vietnam Pro" pitchFamily="34" charset="-120"/>
-              </a:rPr>
-              <a:t> chiếu.</a:t>
+              <a:t> Belkasoft.</a:t>
             </a:r>
             <a:endParaRPr lang="en-US" sz="1800" dirty="0"/>
           </a:p>

</xml_diff>